<commit_message>
feat: finalize on gpt-5.1 run — richer gaps, working calibration, updated decks
gpt-5.1 produced verdict variety (3 IGNORED + 2 UNDER) which unlocked real
logistic calibration (N=15, 11 corroborated). Headline finding is stronger:
5 latent needs the roadmap missed; team shipped 4 within 8-10 months; the #1
(clear account-creation errors) is still unfixed today.

- report sample regenerated (gpt-5.1 + Ant Design)
- pitch-deck.html + Silent_Stakeholder_Pitch.pptx results/closing/confidence
  slides updated to the 5-gap story
- SUBMISSION / PITCH / PITCH_SCRIPT / README numbers refreshed

Co-Authored-By: Claude Opus 4.8 <noreply@anthropic.com>
</commit_message>
<xml_diff>
--- a/docs/Silent_Stakeholder_Pitch.pptx
+++ b/docs/Silent_Stakeholder_Pitch.pptx
@@ -5224,7 +5224,7 @@
                 <a:ea typeface="Calibri" pitchFamily="34" charset="-122"/>
                 <a:cs typeface="Calibri" pitchFamily="34" charset="-120"/>
               </a:rPr>
-              <a:t>RESULTS — VALIDATED</a:t>
+              <a:t>RESULTS — VALIDATED BY HINDSIGHT</a:t>
             </a:r>
             <a:endParaRPr lang="en-US" sz="1200" dirty="0"/>
           </a:p>
@@ -5263,7 +5263,7 @@
                 <a:ea typeface="Calibri" pitchFamily="34" charset="-122"/>
                 <a:cs typeface="Calibri" pitchFamily="34" charset="-120"/>
               </a:rPr>
-              <a:t>3/3 predicted needs were shipped 2–11 months later</a:t>
+              <a:t>Roadmap missed 5 needs — 4 shipped 8–10 months later</a:t>
             </a:r>
             <a:endParaRPr lang="en-US" sz="3200" dirty="0"/>
           </a:p>
@@ -5277,12 +5277,12 @@
         </p:nvSpPr>
         <p:spPr>
           <a:xfrm>
-            <a:off x="640080" y="1828800"/>
-            <a:ext cx="7315200" cy="914400"/>
+            <a:off x="640080" y="1645920"/>
+            <a:ext cx="7040880" cy="731520"/>
           </a:xfrm>
           <a:prstGeom prst="roundRect">
             <a:avLst>
-              <a:gd name="adj" fmla="val 8000"/>
+              <a:gd name="adj" fmla="val 10000"/>
             </a:avLst>
           </a:prstGeom>
           <a:solidFill>
@@ -5311,8 +5311,8 @@
         </p:nvSpPr>
         <p:spPr>
           <a:xfrm>
-            <a:off x="868680" y="2057400"/>
-            <a:ext cx="457200" cy="457200"/>
+            <a:off x="841248" y="1792224"/>
+            <a:ext cx="438912" cy="438912"/>
           </a:xfrm>
           <a:prstGeom prst="ellipse">
             <a:avLst/>
@@ -5331,8 +5331,8 @@
         </p:nvSpPr>
         <p:spPr>
           <a:xfrm>
-            <a:off x="868680" y="2057400"/>
-            <a:ext cx="457200" cy="457200"/>
+            <a:off x="841248" y="1792224"/>
+            <a:ext cx="438912" cy="438912"/>
           </a:xfrm>
           <a:prstGeom prst="rect">
             <a:avLst/>
@@ -5370,24 +5370,24 @@
         </p:nvSpPr>
         <p:spPr>
           <a:xfrm>
-            <a:off x="1508760" y="1938528"/>
-            <a:ext cx="4572000" cy="411480"/>
-          </a:xfrm>
-          <a:prstGeom prst="rect">
-            <a:avLst/>
-          </a:prstGeom>
-          <a:noFill/>
-          <a:ln/>
-        </p:spPr>
-        <p:txBody>
-          <a:bodyPr wrap="square" lIns="0" tIns="0" rIns="0" bIns="0" rtlCol="0" anchor="ctr"/>
-          <a:lstStyle/>
-          <a:p>
-            <a:pPr indent="0" marL="0">
-              <a:buNone/>
-            </a:pPr>
-            <a:r>
-              <a:rPr lang="en-US" sz="1550" b="1" dirty="0">
+            <a:off x="1417320" y="1728216"/>
+            <a:ext cx="4297680" cy="365760"/>
+          </a:xfrm>
+          <a:prstGeom prst="rect">
+            <a:avLst/>
+          </a:prstGeom>
+          <a:noFill/>
+          <a:ln/>
+        </p:spPr>
+        <p:txBody>
+          <a:bodyPr wrap="square" lIns="0" tIns="0" rIns="0" bIns="0" rtlCol="0" anchor="ctr"/>
+          <a:lstStyle/>
+          <a:p>
+            <a:pPr indent="0" marL="0">
+              <a:buNone/>
+            </a:pPr>
+            <a:r>
+              <a:rPr lang="en-US" sz="1400" b="1" dirty="0">
                 <a:solidFill>
                   <a:srgbClr val="E6EDF3"/>
                 </a:solidFill>
@@ -5395,9 +5395,9 @@
                 <a:ea typeface="Calibri" pitchFamily="34" charset="-122"/>
                 <a:cs typeface="Calibri" pitchFamily="34" charset="-120"/>
               </a:rPr>
-              <a:t>Reliable multi-image / media upload</a:t>
-            </a:r>
-            <a:endParaRPr lang="en-US" sz="1550" dirty="0"/>
+              <a:t>Clear errors when creating an account</a:t>
+            </a:r>
+            <a:endParaRPr lang="en-US" sz="1400" dirty="0"/>
           </a:p>
         </p:txBody>
       </p:sp>
@@ -5409,34 +5409,34 @@
         </p:nvSpPr>
         <p:spPr>
           <a:xfrm>
-            <a:off x="1508760" y="2359152"/>
-            <a:ext cx="2926080" cy="292608"/>
-          </a:xfrm>
-          <a:prstGeom prst="rect">
-            <a:avLst/>
-          </a:prstGeom>
-          <a:noFill/>
-          <a:ln/>
-        </p:spPr>
-        <p:txBody>
-          <a:bodyPr wrap="square" lIns="0" tIns="0" rIns="0" bIns="0" rtlCol="0" anchor="ctr"/>
-          <a:lstStyle/>
-          <a:p>
-            <a:pPr indent="0" marL="0">
-              <a:buNone/>
-            </a:pPr>
-            <a:r>
-              <a:rPr lang="en-US" sz="1050" b="1" dirty="0">
-                <a:solidFill>
-                  <a:srgbClr val="D29922"/>
-                </a:solidFill>
-                <a:latin typeface="Calibri" pitchFamily="34" charset="0"/>
-                <a:ea typeface="Calibri" pitchFamily="34" charset="-122"/>
-                <a:cs typeface="Calibri" pitchFamily="34" charset="-120"/>
-              </a:rPr>
-              <a:t>UNDER-PRIORITIZED</a:t>
-            </a:r>
-            <a:endParaRPr lang="en-US" sz="1050" dirty="0"/>
+            <a:off x="1417320" y="2066544"/>
+            <a:ext cx="2926080" cy="237744"/>
+          </a:xfrm>
+          <a:prstGeom prst="rect">
+            <a:avLst/>
+          </a:prstGeom>
+          <a:noFill/>
+          <a:ln/>
+        </p:spPr>
+        <p:txBody>
+          <a:bodyPr wrap="square" lIns="0" tIns="0" rIns="0" bIns="0" rtlCol="0" anchor="ctr"/>
+          <a:lstStyle/>
+          <a:p>
+            <a:pPr indent="0" marL="0">
+              <a:buNone/>
+            </a:pPr>
+            <a:r>
+              <a:rPr lang="en-US" sz="950" b="1" dirty="0">
+                <a:solidFill>
+                  <a:srgbClr val="F85149"/>
+                </a:solidFill>
+                <a:latin typeface="Calibri" pitchFamily="34" charset="0"/>
+                <a:ea typeface="Calibri" pitchFamily="34" charset="-122"/>
+                <a:cs typeface="Calibri" pitchFamily="34" charset="-120"/>
+              </a:rPr>
+              <a:t>IGNORED</a:t>
+            </a:r>
+            <a:endParaRPr lang="en-US" sz="950" dirty="0"/>
           </a:p>
         </p:txBody>
       </p:sp>
@@ -5448,34 +5448,34 @@
         </p:nvSpPr>
         <p:spPr>
           <a:xfrm>
-            <a:off x="6126480" y="2121408"/>
-            <a:ext cx="1097280" cy="365760"/>
-          </a:xfrm>
-          <a:prstGeom prst="rect">
-            <a:avLst/>
-          </a:prstGeom>
-          <a:noFill/>
-          <a:ln/>
-        </p:spPr>
-        <p:txBody>
-          <a:bodyPr wrap="square" lIns="0" tIns="0" rIns="0" bIns="0" rtlCol="0" anchor="ctr"/>
-          <a:lstStyle/>
-          <a:p>
-            <a:pPr indent="0" marL="0">
-              <a:buNone/>
-            </a:pPr>
-            <a:r>
-              <a:rPr lang="en-US" sz="1600" b="1" dirty="0">
-                <a:solidFill>
-                  <a:srgbClr val="E6EDF3"/>
-                </a:solidFill>
-                <a:latin typeface="Calibri" pitchFamily="34" charset="0"/>
-                <a:ea typeface="Calibri" pitchFamily="34" charset="-122"/>
-                <a:cs typeface="Calibri" pitchFamily="34" charset="-120"/>
-              </a:rPr>
-              <a:t>conf 50%</a:t>
-            </a:r>
-            <a:endParaRPr lang="en-US" sz="1600" dirty="0"/>
+            <a:off x="5852160" y="1828800"/>
+            <a:ext cx="1005840" cy="365760"/>
+          </a:xfrm>
+          <a:prstGeom prst="rect">
+            <a:avLst/>
+          </a:prstGeom>
+          <a:noFill/>
+          <a:ln/>
+        </p:spPr>
+        <p:txBody>
+          <a:bodyPr wrap="square" lIns="0" tIns="0" rIns="0" bIns="0" rtlCol="0" anchor="ctr"/>
+          <a:lstStyle/>
+          <a:p>
+            <a:pPr indent="0" marL="0">
+              <a:buNone/>
+            </a:pPr>
+            <a:r>
+              <a:rPr lang="en-US" sz="1500" b="1" dirty="0">
+                <a:solidFill>
+                  <a:srgbClr val="58A6FF"/>
+                </a:solidFill>
+                <a:latin typeface="Calibri" pitchFamily="34" charset="0"/>
+                <a:ea typeface="Calibri" pitchFamily="34" charset="-122"/>
+                <a:cs typeface="Calibri" pitchFamily="34" charset="-120"/>
+              </a:rPr>
+              <a:t>63%</a:t>
+            </a:r>
+            <a:endParaRPr lang="en-US" sz="1500" dirty="0"/>
           </a:p>
         </p:txBody>
       </p:sp>
@@ -5487,12 +5487,295 @@
         </p:nvSpPr>
         <p:spPr>
           <a:xfrm>
-            <a:off x="8138160" y="1828800"/>
-            <a:ext cx="3383280" cy="914400"/>
+            <a:off x="7863840" y="1645920"/>
+            <a:ext cx="3657600" cy="731520"/>
           </a:xfrm>
           <a:prstGeom prst="roundRect">
             <a:avLst>
-              <a:gd name="adj" fmla="val 8000"/>
+              <a:gd name="adj" fmla="val 10000"/>
+            </a:avLst>
+          </a:prstGeom>
+          <a:solidFill>
+            <a:srgbClr val="2A0F12"/>
+          </a:solidFill>
+          <a:ln w="12700">
+            <a:solidFill>
+              <a:srgbClr val="30363D"/>
+            </a:solidFill>
+            <a:prstDash val="solid"/>
+          </a:ln>
+          <a:effectLst>
+            <a:outerShdw sx="100000" sy="100000" kx="0" ky="0" algn="bl" rotWithShape="0" blurRad="101600" dist="38100" dir="5400000">
+              <a:srgbClr val="000000">
+                <a:alpha val="35000"/>
+              </a:srgbClr>
+            </a:outerShdw>
+          </a:effectLst>
+        </p:spPr>
+      </p:sp>
+      <p:sp>
+        <p:nvSpPr>
+          <p:cNvPr id="11" name="Text 9"/>
+          <p:cNvSpPr/>
+          <p:nvPr/>
+        </p:nvSpPr>
+        <p:spPr>
+          <a:xfrm>
+            <a:off x="8046720" y="1847088"/>
+            <a:ext cx="3383280" cy="365760"/>
+          </a:xfrm>
+          <a:prstGeom prst="rect">
+            <a:avLst/>
+          </a:prstGeom>
+          <a:noFill/>
+          <a:ln/>
+        </p:spPr>
+        <p:txBody>
+          <a:bodyPr wrap="square" lIns="0" tIns="0" rIns="0" bIns="0" rtlCol="0" anchor="ctr"/>
+          <a:lstStyle/>
+          <a:p>
+            <a:pPr indent="0" marL="0">
+              <a:buNone/>
+            </a:pPr>
+            <a:r>
+              <a:rPr lang="en-US" sz="1300" b="1" dirty="0">
+                <a:solidFill>
+                  <a:srgbClr val="F85149"/>
+                </a:solidFill>
+                <a:latin typeface="Calibri" pitchFamily="34" charset="0"/>
+                <a:ea typeface="Calibri" pitchFamily="34" charset="-122"/>
+                <a:cs typeface="Calibri" pitchFamily="34" charset="-120"/>
+              </a:rPr>
+              <a:t>still unfixed today</a:t>
+            </a:r>
+            <a:endParaRPr lang="en-US" sz="1300" dirty="0"/>
+          </a:p>
+        </p:txBody>
+      </p:sp>
+      <p:sp>
+        <p:nvSpPr>
+          <p:cNvPr id="12" name="Shape 10"/>
+          <p:cNvSpPr/>
+          <p:nvPr/>
+        </p:nvSpPr>
+        <p:spPr>
+          <a:xfrm>
+            <a:off x="640080" y="2487168"/>
+            <a:ext cx="7040880" cy="731520"/>
+          </a:xfrm>
+          <a:prstGeom prst="roundRect">
+            <a:avLst>
+              <a:gd name="adj" fmla="val 10000"/>
+            </a:avLst>
+          </a:prstGeom>
+          <a:solidFill>
+            <a:srgbClr val="161B22"/>
+          </a:solidFill>
+          <a:ln w="12700">
+            <a:solidFill>
+              <a:srgbClr val="30363D"/>
+            </a:solidFill>
+            <a:prstDash val="solid"/>
+          </a:ln>
+          <a:effectLst>
+            <a:outerShdw sx="100000" sy="100000" kx="0" ky="0" algn="bl" rotWithShape="0" blurRad="101600" dist="38100" dir="5400000">
+              <a:srgbClr val="000000">
+                <a:alpha val="35000"/>
+              </a:srgbClr>
+            </a:outerShdw>
+          </a:effectLst>
+        </p:spPr>
+      </p:sp>
+      <p:sp>
+        <p:nvSpPr>
+          <p:cNvPr id="13" name="Shape 11"/>
+          <p:cNvSpPr/>
+          <p:nvPr/>
+        </p:nvSpPr>
+        <p:spPr>
+          <a:xfrm>
+            <a:off x="841248" y="2633472"/>
+            <a:ext cx="438912" cy="438912"/>
+          </a:xfrm>
+          <a:prstGeom prst="ellipse">
+            <a:avLst/>
+          </a:prstGeom>
+          <a:solidFill>
+            <a:srgbClr val="58A6FF"/>
+          </a:solidFill>
+          <a:ln/>
+        </p:spPr>
+      </p:sp>
+      <p:sp>
+        <p:nvSpPr>
+          <p:cNvPr id="14" name="Text 12"/>
+          <p:cNvSpPr/>
+          <p:nvPr/>
+        </p:nvSpPr>
+        <p:spPr>
+          <a:xfrm>
+            <a:off x="841248" y="2633472"/>
+            <a:ext cx="438912" cy="438912"/>
+          </a:xfrm>
+          <a:prstGeom prst="rect">
+            <a:avLst/>
+          </a:prstGeom>
+          <a:noFill/>
+          <a:ln/>
+        </p:spPr>
+        <p:txBody>
+          <a:bodyPr wrap="square" rtlCol="0" anchor="ctr"/>
+          <a:lstStyle/>
+          <a:p>
+            <a:pPr algn="ctr" indent="0" marL="0">
+              <a:buNone/>
+            </a:pPr>
+            <a:r>
+              <a:rPr lang="en-US" sz="1500" b="1" dirty="0">
+                <a:solidFill>
+                  <a:srgbClr val="0D1117"/>
+                </a:solidFill>
+                <a:latin typeface="Calibri" pitchFamily="34" charset="0"/>
+                <a:ea typeface="Calibri" pitchFamily="34" charset="-122"/>
+                <a:cs typeface="Calibri" pitchFamily="34" charset="-120"/>
+              </a:rPr>
+              <a:t>2</a:t>
+            </a:r>
+            <a:endParaRPr lang="en-US" sz="1500" dirty="0"/>
+          </a:p>
+        </p:txBody>
+      </p:sp>
+      <p:sp>
+        <p:nvSpPr>
+          <p:cNvPr id="15" name="Text 13"/>
+          <p:cNvSpPr/>
+          <p:nvPr/>
+        </p:nvSpPr>
+        <p:spPr>
+          <a:xfrm>
+            <a:off x="1417320" y="2569464"/>
+            <a:ext cx="4297680" cy="365760"/>
+          </a:xfrm>
+          <a:prstGeom prst="rect">
+            <a:avLst/>
+          </a:prstGeom>
+          <a:noFill/>
+          <a:ln/>
+        </p:spPr>
+        <p:txBody>
+          <a:bodyPr wrap="square" lIns="0" tIns="0" rIns="0" bIns="0" rtlCol="0" anchor="ctr"/>
+          <a:lstStyle/>
+          <a:p>
+            <a:pPr indent="0" marL="0">
+              <a:buNone/>
+            </a:pPr>
+            <a:r>
+              <a:rPr lang="en-US" sz="1400" b="1" dirty="0">
+                <a:solidFill>
+                  <a:srgbClr val="E6EDF3"/>
+                </a:solidFill>
+                <a:latin typeface="Calibri" pitchFamily="34" charset="0"/>
+                <a:ea typeface="Calibri" pitchFamily="34" charset="-122"/>
+                <a:cs typeface="Calibri" pitchFamily="34" charset="-120"/>
+              </a:rPr>
+              <a:t>Reliable video attachment in posts</a:t>
+            </a:r>
+            <a:endParaRPr lang="en-US" sz="1400" dirty="0"/>
+          </a:p>
+        </p:txBody>
+      </p:sp>
+      <p:sp>
+        <p:nvSpPr>
+          <p:cNvPr id="16" name="Text 14"/>
+          <p:cNvSpPr/>
+          <p:nvPr/>
+        </p:nvSpPr>
+        <p:spPr>
+          <a:xfrm>
+            <a:off x="1417320" y="2907792"/>
+            <a:ext cx="2926080" cy="237744"/>
+          </a:xfrm>
+          <a:prstGeom prst="rect">
+            <a:avLst/>
+          </a:prstGeom>
+          <a:noFill/>
+          <a:ln/>
+        </p:spPr>
+        <p:txBody>
+          <a:bodyPr wrap="square" lIns="0" tIns="0" rIns="0" bIns="0" rtlCol="0" anchor="ctr"/>
+          <a:lstStyle/>
+          <a:p>
+            <a:pPr indent="0" marL="0">
+              <a:buNone/>
+            </a:pPr>
+            <a:r>
+              <a:rPr lang="en-US" sz="950" b="1" dirty="0">
+                <a:solidFill>
+                  <a:srgbClr val="F85149"/>
+                </a:solidFill>
+                <a:latin typeface="Calibri" pitchFamily="34" charset="0"/>
+                <a:ea typeface="Calibri" pitchFamily="34" charset="-122"/>
+                <a:cs typeface="Calibri" pitchFamily="34" charset="-120"/>
+              </a:rPr>
+              <a:t>IGNORED</a:t>
+            </a:r>
+            <a:endParaRPr lang="en-US" sz="950" dirty="0"/>
+          </a:p>
+        </p:txBody>
+      </p:sp>
+      <p:sp>
+        <p:nvSpPr>
+          <p:cNvPr id="17" name="Text 15"/>
+          <p:cNvSpPr/>
+          <p:nvPr/>
+        </p:nvSpPr>
+        <p:spPr>
+          <a:xfrm>
+            <a:off x="5852160" y="2670048"/>
+            <a:ext cx="1005840" cy="365760"/>
+          </a:xfrm>
+          <a:prstGeom prst="rect">
+            <a:avLst/>
+          </a:prstGeom>
+          <a:noFill/>
+          <a:ln/>
+        </p:spPr>
+        <p:txBody>
+          <a:bodyPr wrap="square" lIns="0" tIns="0" rIns="0" bIns="0" rtlCol="0" anchor="ctr"/>
+          <a:lstStyle/>
+          <a:p>
+            <a:pPr indent="0" marL="0">
+              <a:buNone/>
+            </a:pPr>
+            <a:r>
+              <a:rPr lang="en-US" sz="1500" b="1" dirty="0">
+                <a:solidFill>
+                  <a:srgbClr val="58A6FF"/>
+                </a:solidFill>
+                <a:latin typeface="Calibri" pitchFamily="34" charset="0"/>
+                <a:ea typeface="Calibri" pitchFamily="34" charset="-122"/>
+                <a:cs typeface="Calibri" pitchFamily="34" charset="-120"/>
+              </a:rPr>
+              <a:t>63%</a:t>
+            </a:r>
+            <a:endParaRPr lang="en-US" sz="1500" dirty="0"/>
+          </a:p>
+        </p:txBody>
+      </p:sp>
+      <p:sp>
+        <p:nvSpPr>
+          <p:cNvPr id="18" name="Shape 16"/>
+          <p:cNvSpPr/>
+          <p:nvPr/>
+        </p:nvSpPr>
+        <p:spPr>
+          <a:xfrm>
+            <a:off x="7863840" y="2487168"/>
+            <a:ext cx="3657600" cy="731520"/>
+          </a:xfrm>
+          <a:prstGeom prst="roundRect">
+            <a:avLst>
+              <a:gd name="adj" fmla="val 10000"/>
             </a:avLst>
           </a:prstGeom>
           <a:solidFill>
@@ -5515,30 +5798,30 @@
       </p:sp>
       <p:sp>
         <p:nvSpPr>
-          <p:cNvPr id="11" name="Text 9"/>
-          <p:cNvSpPr/>
-          <p:nvPr/>
-        </p:nvSpPr>
-        <p:spPr>
-          <a:xfrm>
-            <a:off x="8321040" y="2103120"/>
-            <a:ext cx="3017520" cy="365760"/>
-          </a:xfrm>
-          <a:prstGeom prst="rect">
-            <a:avLst/>
-          </a:prstGeom>
-          <a:noFill/>
-          <a:ln/>
-        </p:spPr>
-        <p:txBody>
-          <a:bodyPr wrap="square" lIns="0" tIns="0" rIns="0" bIns="0" rtlCol="0" anchor="ctr"/>
-          <a:lstStyle/>
-          <a:p>
-            <a:pPr indent="0" marL="0">
-              <a:buNone/>
-            </a:pPr>
-            <a:r>
-              <a:rPr lang="en-US" sz="1500" b="1" dirty="0">
+          <p:cNvPr id="19" name="Text 17"/>
+          <p:cNvSpPr/>
+          <p:nvPr/>
+        </p:nvSpPr>
+        <p:spPr>
+          <a:xfrm>
+            <a:off x="8046720" y="2688336"/>
+            <a:ext cx="3383280" cy="365760"/>
+          </a:xfrm>
+          <a:prstGeom prst="rect">
+            <a:avLst/>
+          </a:prstGeom>
+          <a:noFill/>
+          <a:ln/>
+        </p:spPr>
+        <p:txBody>
+          <a:bodyPr wrap="square" lIns="0" tIns="0" rIns="0" bIns="0" rtlCol="0" anchor="ctr"/>
+          <a:lstStyle/>
+          <a:p>
+            <a:pPr indent="0" marL="0">
+              <a:buNone/>
+            </a:pPr>
+            <a:r>
+              <a:rPr lang="en-US" sz="1300" b="1" dirty="0">
                 <a:solidFill>
                   <a:srgbClr val="3FB950"/>
                 </a:solidFill>
@@ -5546,40 +5829,26 @@
                 <a:ea typeface="Calibri" pitchFamily="34" charset="-122"/>
                 <a:cs typeface="Calibri" pitchFamily="34" charset="-120"/>
               </a:rPr>
-              <a:t>shipped GH-5434  </a:t>
-            </a:r>
-            <a:pPr indent="0" marL="0">
-              <a:buNone/>
-            </a:pPr>
-            <a:r>
-              <a:rPr lang="en-US" sz="1500" b="1" dirty="0">
-                <a:solidFill>
-                  <a:srgbClr val="E6EDF3"/>
-                </a:solidFill>
-                <a:latin typeface="Calibri" pitchFamily="34" charset="0"/>
-                <a:ea typeface="Calibri" pitchFamily="34" charset="-122"/>
-                <a:cs typeface="Calibri" pitchFamily="34" charset="-120"/>
-              </a:rPr>
-              <a:t>+2 mo</a:t>
-            </a:r>
-            <a:endParaRPr lang="en-US" sz="1500" dirty="0"/>
-          </a:p>
-        </p:txBody>
-      </p:sp>
-      <p:sp>
-        <p:nvSpPr>
-          <p:cNvPr id="12" name="Shape 10"/>
-          <p:cNvSpPr/>
-          <p:nvPr/>
-        </p:nvSpPr>
-        <p:spPr>
-          <a:xfrm>
-            <a:off x="640080" y="2880360"/>
-            <a:ext cx="7315200" cy="914400"/>
+              <a:t>+8 mo · GH-6654</a:t>
+            </a:r>
+            <a:endParaRPr lang="en-US" sz="1300" dirty="0"/>
+          </a:p>
+        </p:txBody>
+      </p:sp>
+      <p:sp>
+        <p:nvSpPr>
+          <p:cNvPr id="20" name="Shape 18"/>
+          <p:cNvSpPr/>
+          <p:nvPr/>
+        </p:nvSpPr>
+        <p:spPr>
+          <a:xfrm>
+            <a:off x="640080" y="3328416"/>
+            <a:ext cx="7040880" cy="731520"/>
           </a:xfrm>
           <a:prstGeom prst="roundRect">
             <a:avLst>
-              <a:gd name="adj" fmla="val 8000"/>
+              <a:gd name="adj" fmla="val 10000"/>
             </a:avLst>
           </a:prstGeom>
           <a:solidFill>
@@ -5602,14 +5871,14 @@
       </p:sp>
       <p:sp>
         <p:nvSpPr>
-          <p:cNvPr id="13" name="Shape 11"/>
-          <p:cNvSpPr/>
-          <p:nvPr/>
-        </p:nvSpPr>
-        <p:spPr>
-          <a:xfrm>
-            <a:off x="868680" y="3108960"/>
-            <a:ext cx="457200" cy="457200"/>
+          <p:cNvPr id="21" name="Shape 19"/>
+          <p:cNvSpPr/>
+          <p:nvPr/>
+        </p:nvSpPr>
+        <p:spPr>
+          <a:xfrm>
+            <a:off x="841248" y="3474720"/>
+            <a:ext cx="438912" cy="438912"/>
           </a:xfrm>
           <a:prstGeom prst="ellipse">
             <a:avLst/>
@@ -5622,14 +5891,14 @@
       </p:sp>
       <p:sp>
         <p:nvSpPr>
-          <p:cNvPr id="14" name="Text 12"/>
-          <p:cNvSpPr/>
-          <p:nvPr/>
-        </p:nvSpPr>
-        <p:spPr>
-          <a:xfrm>
-            <a:off x="868680" y="3108960"/>
-            <a:ext cx="457200" cy="457200"/>
+          <p:cNvPr id="22" name="Text 20"/>
+          <p:cNvSpPr/>
+          <p:nvPr/>
+        </p:nvSpPr>
+        <p:spPr>
+          <a:xfrm>
+            <a:off x="841248" y="3474720"/>
+            <a:ext cx="438912" cy="438912"/>
           </a:xfrm>
           <a:prstGeom prst="rect">
             <a:avLst/>
@@ -5653,7 +5922,7 @@
                 <a:ea typeface="Calibri" pitchFamily="34" charset="-122"/>
                 <a:cs typeface="Calibri" pitchFamily="34" charset="-120"/>
               </a:rPr>
-              <a:t>2</a:t>
+              <a:t>3</a:t>
             </a:r>
             <a:endParaRPr lang="en-US" sz="1500" dirty="0"/>
           </a:p>
@@ -5661,30 +5930,30 @@
       </p:sp>
       <p:sp>
         <p:nvSpPr>
-          <p:cNvPr id="15" name="Text 13"/>
-          <p:cNvSpPr/>
-          <p:nvPr/>
-        </p:nvSpPr>
-        <p:spPr>
-          <a:xfrm>
-            <a:off x="1508760" y="2990088"/>
-            <a:ext cx="4572000" cy="411480"/>
-          </a:xfrm>
-          <a:prstGeom prst="rect">
-            <a:avLst/>
-          </a:prstGeom>
-          <a:noFill/>
-          <a:ln/>
-        </p:spPr>
-        <p:txBody>
-          <a:bodyPr wrap="square" lIns="0" tIns="0" rIns="0" bIns="0" rtlCol="0" anchor="ctr"/>
-          <a:lstStyle/>
-          <a:p>
-            <a:pPr indent="0" marL="0">
-              <a:buNone/>
-            </a:pPr>
-            <a:r>
-              <a:rPr lang="en-US" sz="1550" b="1" dirty="0">
+          <p:cNvPr id="23" name="Text 21"/>
+          <p:cNvSpPr/>
+          <p:nvPr/>
+        </p:nvSpPr>
+        <p:spPr>
+          <a:xfrm>
+            <a:off x="1417320" y="3410712"/>
+            <a:ext cx="4297680" cy="365760"/>
+          </a:xfrm>
+          <a:prstGeom prst="rect">
+            <a:avLst/>
+          </a:prstGeom>
+          <a:noFill/>
+          <a:ln/>
+        </p:spPr>
+        <p:txBody>
+          <a:bodyPr wrap="square" lIns="0" tIns="0" rIns="0" bIns="0" rtlCol="0" anchor="ctr"/>
+          <a:lstStyle/>
+          <a:p>
+            <a:pPr indent="0" marL="0">
+              <a:buNone/>
+            </a:pPr>
+            <a:r>
+              <a:rPr lang="en-US" sz="1400" b="1" dirty="0">
                 <a:solidFill>
                   <a:srgbClr val="E6EDF3"/>
                 </a:solidFill>
@@ -5692,104 +5961,104 @@
                 <a:ea typeface="Calibri" pitchFamily="34" charset="-122"/>
                 <a:cs typeface="Calibri" pitchFamily="34" charset="-120"/>
               </a:rPr>
-              <a:t>Consistent text-formatting in the editor</a:t>
-            </a:r>
-            <a:endParaRPr lang="en-US" sz="1550" dirty="0"/>
-          </a:p>
-        </p:txBody>
-      </p:sp>
-      <p:sp>
-        <p:nvSpPr>
-          <p:cNvPr id="16" name="Text 14"/>
-          <p:cNvSpPr/>
-          <p:nvPr/>
-        </p:nvSpPr>
-        <p:spPr>
-          <a:xfrm>
-            <a:off x="1508760" y="3410712"/>
-            <a:ext cx="2926080" cy="292608"/>
-          </a:xfrm>
-          <a:prstGeom prst="rect">
-            <a:avLst/>
-          </a:prstGeom>
-          <a:noFill/>
-          <a:ln/>
-        </p:spPr>
-        <p:txBody>
-          <a:bodyPr wrap="square" lIns="0" tIns="0" rIns="0" bIns="0" rtlCol="0" anchor="ctr"/>
-          <a:lstStyle/>
-          <a:p>
-            <a:pPr indent="0" marL="0">
-              <a:buNone/>
-            </a:pPr>
-            <a:r>
-              <a:rPr lang="en-US" sz="1050" b="1" dirty="0">
-                <a:solidFill>
-                  <a:srgbClr val="D29922"/>
-                </a:solidFill>
-                <a:latin typeface="Calibri" pitchFamily="34" charset="0"/>
-                <a:ea typeface="Calibri" pitchFamily="34" charset="-122"/>
-                <a:cs typeface="Calibri" pitchFamily="34" charset="-120"/>
-              </a:rPr>
-              <a:t>UNDER-PRIORITIZED</a:t>
-            </a:r>
-            <a:endParaRPr lang="en-US" sz="1050" dirty="0"/>
-          </a:p>
-        </p:txBody>
-      </p:sp>
-      <p:sp>
-        <p:nvSpPr>
-          <p:cNvPr id="17" name="Text 15"/>
-          <p:cNvSpPr/>
-          <p:nvPr/>
-        </p:nvSpPr>
-        <p:spPr>
-          <a:xfrm>
-            <a:off x="6126480" y="3172968"/>
-            <a:ext cx="1097280" cy="365760"/>
-          </a:xfrm>
-          <a:prstGeom prst="rect">
-            <a:avLst/>
-          </a:prstGeom>
-          <a:noFill/>
-          <a:ln/>
-        </p:spPr>
-        <p:txBody>
-          <a:bodyPr wrap="square" lIns="0" tIns="0" rIns="0" bIns="0" rtlCol="0" anchor="ctr"/>
-          <a:lstStyle/>
-          <a:p>
-            <a:pPr indent="0" marL="0">
-              <a:buNone/>
-            </a:pPr>
-            <a:r>
-              <a:rPr lang="en-US" sz="1600" b="1" dirty="0">
-                <a:solidFill>
-                  <a:srgbClr val="E6EDF3"/>
-                </a:solidFill>
-                <a:latin typeface="Calibri" pitchFamily="34" charset="0"/>
-                <a:ea typeface="Calibri" pitchFamily="34" charset="-122"/>
-                <a:cs typeface="Calibri" pitchFamily="34" charset="-120"/>
-              </a:rPr>
-              <a:t>conf 47%</a:t>
-            </a:r>
-            <a:endParaRPr lang="en-US" sz="1600" dirty="0"/>
-          </a:p>
-        </p:txBody>
-      </p:sp>
-      <p:sp>
-        <p:nvSpPr>
-          <p:cNvPr id="18" name="Shape 16"/>
-          <p:cNvSpPr/>
-          <p:nvPr/>
-        </p:nvSpPr>
-        <p:spPr>
-          <a:xfrm>
-            <a:off x="8138160" y="2880360"/>
-            <a:ext cx="3383280" cy="914400"/>
+              <a:t>Posts load &amp; refresh after login</a:t>
+            </a:r>
+            <a:endParaRPr lang="en-US" sz="1400" dirty="0"/>
+          </a:p>
+        </p:txBody>
+      </p:sp>
+      <p:sp>
+        <p:nvSpPr>
+          <p:cNvPr id="24" name="Text 22"/>
+          <p:cNvSpPr/>
+          <p:nvPr/>
+        </p:nvSpPr>
+        <p:spPr>
+          <a:xfrm>
+            <a:off x="1417320" y="3749040"/>
+            <a:ext cx="2926080" cy="237744"/>
+          </a:xfrm>
+          <a:prstGeom prst="rect">
+            <a:avLst/>
+          </a:prstGeom>
+          <a:noFill/>
+          <a:ln/>
+        </p:spPr>
+        <p:txBody>
+          <a:bodyPr wrap="square" lIns="0" tIns="0" rIns="0" bIns="0" rtlCol="0" anchor="ctr"/>
+          <a:lstStyle/>
+          <a:p>
+            <a:pPr indent="0" marL="0">
+              <a:buNone/>
+            </a:pPr>
+            <a:r>
+              <a:rPr lang="en-US" sz="950" b="1" dirty="0">
+                <a:solidFill>
+                  <a:srgbClr val="F85149"/>
+                </a:solidFill>
+                <a:latin typeface="Calibri" pitchFamily="34" charset="0"/>
+                <a:ea typeface="Calibri" pitchFamily="34" charset="-122"/>
+                <a:cs typeface="Calibri" pitchFamily="34" charset="-120"/>
+              </a:rPr>
+              <a:t>IGNORED</a:t>
+            </a:r>
+            <a:endParaRPr lang="en-US" sz="950" dirty="0"/>
+          </a:p>
+        </p:txBody>
+      </p:sp>
+      <p:sp>
+        <p:nvSpPr>
+          <p:cNvPr id="25" name="Text 23"/>
+          <p:cNvSpPr/>
+          <p:nvPr/>
+        </p:nvSpPr>
+        <p:spPr>
+          <a:xfrm>
+            <a:off x="5852160" y="3511296"/>
+            <a:ext cx="1005840" cy="365760"/>
+          </a:xfrm>
+          <a:prstGeom prst="rect">
+            <a:avLst/>
+          </a:prstGeom>
+          <a:noFill/>
+          <a:ln/>
+        </p:spPr>
+        <p:txBody>
+          <a:bodyPr wrap="square" lIns="0" tIns="0" rIns="0" bIns="0" rtlCol="0" anchor="ctr"/>
+          <a:lstStyle/>
+          <a:p>
+            <a:pPr indent="0" marL="0">
+              <a:buNone/>
+            </a:pPr>
+            <a:r>
+              <a:rPr lang="en-US" sz="1500" b="1" dirty="0">
+                <a:solidFill>
+                  <a:srgbClr val="58A6FF"/>
+                </a:solidFill>
+                <a:latin typeface="Calibri" pitchFamily="34" charset="0"/>
+                <a:ea typeface="Calibri" pitchFamily="34" charset="-122"/>
+                <a:cs typeface="Calibri" pitchFamily="34" charset="-120"/>
+              </a:rPr>
+              <a:t>62%</a:t>
+            </a:r>
+            <a:endParaRPr lang="en-US" sz="1500" dirty="0"/>
+          </a:p>
+        </p:txBody>
+      </p:sp>
+      <p:sp>
+        <p:nvSpPr>
+          <p:cNvPr id="26" name="Shape 24"/>
+          <p:cNvSpPr/>
+          <p:nvPr/>
+        </p:nvSpPr>
+        <p:spPr>
+          <a:xfrm>
+            <a:off x="7863840" y="3328416"/>
+            <a:ext cx="3657600" cy="731520"/>
           </a:xfrm>
           <a:prstGeom prst="roundRect">
             <a:avLst>
-              <a:gd name="adj" fmla="val 8000"/>
+              <a:gd name="adj" fmla="val 10000"/>
             </a:avLst>
           </a:prstGeom>
           <a:solidFill>
@@ -5812,30 +6081,30 @@
       </p:sp>
       <p:sp>
         <p:nvSpPr>
-          <p:cNvPr id="19" name="Text 17"/>
-          <p:cNvSpPr/>
-          <p:nvPr/>
-        </p:nvSpPr>
-        <p:spPr>
-          <a:xfrm>
-            <a:off x="8321040" y="3154680"/>
-            <a:ext cx="3017520" cy="365760"/>
-          </a:xfrm>
-          <a:prstGeom prst="rect">
-            <a:avLst/>
-          </a:prstGeom>
-          <a:noFill/>
-          <a:ln/>
-        </p:spPr>
-        <p:txBody>
-          <a:bodyPr wrap="square" lIns="0" tIns="0" rIns="0" bIns="0" rtlCol="0" anchor="ctr"/>
-          <a:lstStyle/>
-          <a:p>
-            <a:pPr indent="0" marL="0">
-              <a:buNone/>
-            </a:pPr>
-            <a:r>
-              <a:rPr lang="en-US" sz="1500" b="1" dirty="0">
+          <p:cNvPr id="27" name="Text 25"/>
+          <p:cNvSpPr/>
+          <p:nvPr/>
+        </p:nvSpPr>
+        <p:spPr>
+          <a:xfrm>
+            <a:off x="8046720" y="3529584"/>
+            <a:ext cx="3383280" cy="365760"/>
+          </a:xfrm>
+          <a:prstGeom prst="rect">
+            <a:avLst/>
+          </a:prstGeom>
+          <a:noFill/>
+          <a:ln/>
+        </p:spPr>
+        <p:txBody>
+          <a:bodyPr wrap="square" lIns="0" tIns="0" rIns="0" bIns="0" rtlCol="0" anchor="ctr"/>
+          <a:lstStyle/>
+          <a:p>
+            <a:pPr indent="0" marL="0">
+              <a:buNone/>
+            </a:pPr>
+            <a:r>
+              <a:rPr lang="en-US" sz="1300" b="1" dirty="0">
                 <a:solidFill>
                   <a:srgbClr val="3FB950"/>
                 </a:solidFill>
@@ -5843,40 +6112,26 @@
                 <a:ea typeface="Calibri" pitchFamily="34" charset="-122"/>
                 <a:cs typeface="Calibri" pitchFamily="34" charset="-120"/>
               </a:rPr>
-              <a:t>shipped GH-5685  </a:t>
-            </a:r>
-            <a:pPr indent="0" marL="0">
-              <a:buNone/>
-            </a:pPr>
-            <a:r>
-              <a:rPr lang="en-US" sz="1500" b="1" dirty="0">
-                <a:solidFill>
-                  <a:srgbClr val="E6EDF3"/>
-                </a:solidFill>
-                <a:latin typeface="Calibri" pitchFamily="34" charset="0"/>
-                <a:ea typeface="Calibri" pitchFamily="34" charset="-122"/>
-                <a:cs typeface="Calibri" pitchFamily="34" charset="-120"/>
-              </a:rPr>
-              <a:t>+3 mo</a:t>
-            </a:r>
-            <a:endParaRPr lang="en-US" sz="1500" dirty="0"/>
-          </a:p>
-        </p:txBody>
-      </p:sp>
-      <p:sp>
-        <p:nvSpPr>
-          <p:cNvPr id="20" name="Shape 18"/>
-          <p:cNvSpPr/>
-          <p:nvPr/>
-        </p:nvSpPr>
-        <p:spPr>
-          <a:xfrm>
-            <a:off x="640080" y="3931920"/>
-            <a:ext cx="7315200" cy="914400"/>
+              <a:t>+10 mo · GH-5874</a:t>
+            </a:r>
+            <a:endParaRPr lang="en-US" sz="1300" dirty="0"/>
+          </a:p>
+        </p:txBody>
+      </p:sp>
+      <p:sp>
+        <p:nvSpPr>
+          <p:cNvPr id="28" name="Shape 26"/>
+          <p:cNvSpPr/>
+          <p:nvPr/>
+        </p:nvSpPr>
+        <p:spPr>
+          <a:xfrm>
+            <a:off x="640080" y="4169664"/>
+            <a:ext cx="7040880" cy="731520"/>
           </a:xfrm>
           <a:prstGeom prst="roundRect">
             <a:avLst>
-              <a:gd name="adj" fmla="val 8000"/>
+              <a:gd name="adj" fmla="val 10000"/>
             </a:avLst>
           </a:prstGeom>
           <a:solidFill>
@@ -5899,14 +6154,14 @@
       </p:sp>
       <p:sp>
         <p:nvSpPr>
-          <p:cNvPr id="21" name="Shape 19"/>
-          <p:cNvSpPr/>
-          <p:nvPr/>
-        </p:nvSpPr>
-        <p:spPr>
-          <a:xfrm>
-            <a:off x="868680" y="4160520"/>
-            <a:ext cx="457200" cy="457200"/>
+          <p:cNvPr id="29" name="Shape 27"/>
+          <p:cNvSpPr/>
+          <p:nvPr/>
+        </p:nvSpPr>
+        <p:spPr>
+          <a:xfrm>
+            <a:off x="841248" y="4315968"/>
+            <a:ext cx="438912" cy="438912"/>
           </a:xfrm>
           <a:prstGeom prst="ellipse">
             <a:avLst/>
@@ -5919,14 +6174,14 @@
       </p:sp>
       <p:sp>
         <p:nvSpPr>
-          <p:cNvPr id="22" name="Text 20"/>
-          <p:cNvSpPr/>
-          <p:nvPr/>
-        </p:nvSpPr>
-        <p:spPr>
-          <a:xfrm>
-            <a:off x="868680" y="4160520"/>
-            <a:ext cx="457200" cy="457200"/>
+          <p:cNvPr id="30" name="Text 28"/>
+          <p:cNvSpPr/>
+          <p:nvPr/>
+        </p:nvSpPr>
+        <p:spPr>
+          <a:xfrm>
+            <a:off x="841248" y="4315968"/>
+            <a:ext cx="438912" cy="438912"/>
           </a:xfrm>
           <a:prstGeom prst="rect">
             <a:avLst/>
@@ -5950,7 +6205,7 @@
                 <a:ea typeface="Calibri" pitchFamily="34" charset="-122"/>
                 <a:cs typeface="Calibri" pitchFamily="34" charset="-120"/>
               </a:rPr>
-              <a:t>3</a:t>
+              <a:t>4</a:t>
             </a:r>
             <a:endParaRPr lang="en-US" sz="1500" dirty="0"/>
           </a:p>
@@ -5958,30 +6213,30 @@
       </p:sp>
       <p:sp>
         <p:nvSpPr>
-          <p:cNvPr id="23" name="Text 21"/>
-          <p:cNvSpPr/>
-          <p:nvPr/>
-        </p:nvSpPr>
-        <p:spPr>
-          <a:xfrm>
-            <a:off x="1508760" y="4041648"/>
-            <a:ext cx="4572000" cy="411480"/>
-          </a:xfrm>
-          <a:prstGeom prst="rect">
-            <a:avLst/>
-          </a:prstGeom>
-          <a:noFill/>
-          <a:ln/>
-        </p:spPr>
-        <p:txBody>
-          <a:bodyPr wrap="square" lIns="0" tIns="0" rIns="0" bIns="0" rtlCol="0" anchor="ctr"/>
-          <a:lstStyle/>
-          <a:p>
-            <a:pPr indent="0" marL="0">
-              <a:buNone/>
-            </a:pPr>
-            <a:r>
-              <a:rPr lang="en-US" sz="1550" b="1" dirty="0">
+          <p:cNvPr id="31" name="Text 29"/>
+          <p:cNvSpPr/>
+          <p:nvPr/>
+        </p:nvSpPr>
+        <p:spPr>
+          <a:xfrm>
+            <a:off x="1417320" y="4251960"/>
+            <a:ext cx="4297680" cy="365760"/>
+          </a:xfrm>
+          <a:prstGeom prst="rect">
+            <a:avLst/>
+          </a:prstGeom>
+          <a:noFill/>
+          <a:ln/>
+        </p:spPr>
+        <p:txBody>
+          <a:bodyPr wrap="square" lIns="0" tIns="0" rIns="0" bIns="0" rtlCol="0" anchor="ctr"/>
+          <a:lstStyle/>
+          <a:p>
+            <a:pPr indent="0" marL="0">
+              <a:buNone/>
+            </a:pPr>
+            <a:r>
+              <a:rPr lang="en-US" sz="1400" b="1" dirty="0">
                 <a:solidFill>
                   <a:srgbClr val="E6EDF3"/>
                 </a:solidFill>
@@ -5989,38 +6244,38 @@
                 <a:ea typeface="Calibri" pitchFamily="34" charset="-122"/>
                 <a:cs typeface="Calibri" pitchFamily="34" charset="-120"/>
               </a:rPr>
-              <a:t>Reliable media-library experience</a:t>
-            </a:r>
-            <a:endParaRPr lang="en-US" sz="1550" dirty="0"/>
-          </a:p>
-        </p:txBody>
-      </p:sp>
-      <p:sp>
-        <p:nvSpPr>
-          <p:cNvPr id="24" name="Text 22"/>
-          <p:cNvSpPr/>
-          <p:nvPr/>
-        </p:nvSpPr>
-        <p:spPr>
-          <a:xfrm>
-            <a:off x="1508760" y="4462272"/>
-            <a:ext cx="2926080" cy="292608"/>
-          </a:xfrm>
-          <a:prstGeom prst="rect">
-            <a:avLst/>
-          </a:prstGeom>
-          <a:noFill/>
-          <a:ln/>
-        </p:spPr>
-        <p:txBody>
-          <a:bodyPr wrap="square" lIns="0" tIns="0" rIns="0" bIns="0" rtlCol="0" anchor="ctr"/>
-          <a:lstStyle/>
-          <a:p>
-            <a:pPr indent="0" marL="0">
-              <a:buNone/>
-            </a:pPr>
-            <a:r>
-              <a:rPr lang="en-US" sz="1050" b="1" dirty="0">
+              <a:t>Reply / comment on comments in-app</a:t>
+            </a:r>
+            <a:endParaRPr lang="en-US" sz="1400" dirty="0"/>
+          </a:p>
+        </p:txBody>
+      </p:sp>
+      <p:sp>
+        <p:nvSpPr>
+          <p:cNvPr id="32" name="Text 30"/>
+          <p:cNvSpPr/>
+          <p:nvPr/>
+        </p:nvSpPr>
+        <p:spPr>
+          <a:xfrm>
+            <a:off x="1417320" y="4590288"/>
+            <a:ext cx="2926080" cy="237744"/>
+          </a:xfrm>
+          <a:prstGeom prst="rect">
+            <a:avLst/>
+          </a:prstGeom>
+          <a:noFill/>
+          <a:ln/>
+        </p:spPr>
+        <p:txBody>
+          <a:bodyPr wrap="square" lIns="0" tIns="0" rIns="0" bIns="0" rtlCol="0" anchor="ctr"/>
+          <a:lstStyle/>
+          <a:p>
+            <a:pPr indent="0" marL="0">
+              <a:buNone/>
+            </a:pPr>
+            <a:r>
+              <a:rPr lang="en-US" sz="950" b="1" dirty="0">
                 <a:solidFill>
                   <a:srgbClr val="D29922"/>
                 </a:solidFill>
@@ -6030,63 +6285,63 @@
               </a:rPr>
               <a:t>UNDER-PRIORITIZED</a:t>
             </a:r>
-            <a:endParaRPr lang="en-US" sz="1050" dirty="0"/>
-          </a:p>
-        </p:txBody>
-      </p:sp>
-      <p:sp>
-        <p:nvSpPr>
-          <p:cNvPr id="25" name="Text 23"/>
-          <p:cNvSpPr/>
-          <p:nvPr/>
-        </p:nvSpPr>
-        <p:spPr>
-          <a:xfrm>
-            <a:off x="6126480" y="4224528"/>
-            <a:ext cx="1097280" cy="365760"/>
-          </a:xfrm>
-          <a:prstGeom prst="rect">
-            <a:avLst/>
-          </a:prstGeom>
-          <a:noFill/>
-          <a:ln/>
-        </p:spPr>
-        <p:txBody>
-          <a:bodyPr wrap="square" lIns="0" tIns="0" rIns="0" bIns="0" rtlCol="0" anchor="ctr"/>
-          <a:lstStyle/>
-          <a:p>
-            <a:pPr indent="0" marL="0">
-              <a:buNone/>
-            </a:pPr>
-            <a:r>
-              <a:rPr lang="en-US" sz="1600" b="1" dirty="0">
-                <a:solidFill>
-                  <a:srgbClr val="E6EDF3"/>
-                </a:solidFill>
-                <a:latin typeface="Calibri" pitchFamily="34" charset="0"/>
-                <a:ea typeface="Calibri" pitchFamily="34" charset="-122"/>
-                <a:cs typeface="Calibri" pitchFamily="34" charset="-120"/>
-              </a:rPr>
-              <a:t>conf 45%</a:t>
-            </a:r>
-            <a:endParaRPr lang="en-US" sz="1600" dirty="0"/>
-          </a:p>
-        </p:txBody>
-      </p:sp>
-      <p:sp>
-        <p:nvSpPr>
-          <p:cNvPr id="26" name="Shape 24"/>
-          <p:cNvSpPr/>
-          <p:nvPr/>
-        </p:nvSpPr>
-        <p:spPr>
-          <a:xfrm>
-            <a:off x="8138160" y="3931920"/>
-            <a:ext cx="3383280" cy="914400"/>
+            <a:endParaRPr lang="en-US" sz="950" dirty="0"/>
+          </a:p>
+        </p:txBody>
+      </p:sp>
+      <p:sp>
+        <p:nvSpPr>
+          <p:cNvPr id="33" name="Text 31"/>
+          <p:cNvSpPr/>
+          <p:nvPr/>
+        </p:nvSpPr>
+        <p:spPr>
+          <a:xfrm>
+            <a:off x="5852160" y="4352544"/>
+            <a:ext cx="1005840" cy="365760"/>
+          </a:xfrm>
+          <a:prstGeom prst="rect">
+            <a:avLst/>
+          </a:prstGeom>
+          <a:noFill/>
+          <a:ln/>
+        </p:spPr>
+        <p:txBody>
+          <a:bodyPr wrap="square" lIns="0" tIns="0" rIns="0" bIns="0" rtlCol="0" anchor="ctr"/>
+          <a:lstStyle/>
+          <a:p>
+            <a:pPr indent="0" marL="0">
+              <a:buNone/>
+            </a:pPr>
+            <a:r>
+              <a:rPr lang="en-US" sz="1500" b="1" dirty="0">
+                <a:solidFill>
+                  <a:srgbClr val="58A6FF"/>
+                </a:solidFill>
+                <a:latin typeface="Calibri" pitchFamily="34" charset="0"/>
+                <a:ea typeface="Calibri" pitchFamily="34" charset="-122"/>
+                <a:cs typeface="Calibri" pitchFamily="34" charset="-120"/>
+              </a:rPr>
+              <a:t>57%</a:t>
+            </a:r>
+            <a:endParaRPr lang="en-US" sz="1500" dirty="0"/>
+          </a:p>
+        </p:txBody>
+      </p:sp>
+      <p:sp>
+        <p:nvSpPr>
+          <p:cNvPr id="34" name="Shape 32"/>
+          <p:cNvSpPr/>
+          <p:nvPr/>
+        </p:nvSpPr>
+        <p:spPr>
+          <a:xfrm>
+            <a:off x="7863840" y="4169664"/>
+            <a:ext cx="3657600" cy="731520"/>
           </a:xfrm>
           <a:prstGeom prst="roundRect">
             <a:avLst>
-              <a:gd name="adj" fmla="val 8000"/>
+              <a:gd name="adj" fmla="val 10000"/>
             </a:avLst>
           </a:prstGeom>
           <a:solidFill>
@@ -6109,66 +6364,335 @@
       </p:sp>
       <p:sp>
         <p:nvSpPr>
-          <p:cNvPr id="27" name="Text 25"/>
-          <p:cNvSpPr/>
-          <p:nvPr/>
-        </p:nvSpPr>
-        <p:spPr>
-          <a:xfrm>
-            <a:off x="8321040" y="4206240"/>
-            <a:ext cx="3017520" cy="365760"/>
-          </a:xfrm>
-          <a:prstGeom prst="rect">
-            <a:avLst/>
-          </a:prstGeom>
-          <a:noFill/>
-          <a:ln/>
-        </p:spPr>
-        <p:txBody>
-          <a:bodyPr wrap="square" lIns="0" tIns="0" rIns="0" bIns="0" rtlCol="0" anchor="ctr"/>
-          <a:lstStyle/>
-          <a:p>
-            <a:pPr indent="0" marL="0">
+          <p:cNvPr id="35" name="Text 33"/>
+          <p:cNvSpPr/>
+          <p:nvPr/>
+        </p:nvSpPr>
+        <p:spPr>
+          <a:xfrm>
+            <a:off x="8046720" y="4370832"/>
+            <a:ext cx="3383280" cy="365760"/>
+          </a:xfrm>
+          <a:prstGeom prst="rect">
+            <a:avLst/>
+          </a:prstGeom>
+          <a:noFill/>
+          <a:ln/>
+        </p:spPr>
+        <p:txBody>
+          <a:bodyPr wrap="square" lIns="0" tIns="0" rIns="0" bIns="0" rtlCol="0" anchor="ctr"/>
+          <a:lstStyle/>
+          <a:p>
+            <a:pPr indent="0" marL="0">
+              <a:buNone/>
+            </a:pPr>
+            <a:r>
+              <a:rPr lang="en-US" sz="1300" b="1" dirty="0">
+                <a:solidFill>
+                  <a:srgbClr val="3FB950"/>
+                </a:solidFill>
+                <a:latin typeface="Calibri" pitchFamily="34" charset="0"/>
+                <a:ea typeface="Calibri" pitchFamily="34" charset="-122"/>
+                <a:cs typeface="Calibri" pitchFamily="34" charset="-120"/>
+              </a:rPr>
+              <a:t>+9 mo · GH-6769</a:t>
+            </a:r>
+            <a:endParaRPr lang="en-US" sz="1300" dirty="0"/>
+          </a:p>
+        </p:txBody>
+      </p:sp>
+      <p:sp>
+        <p:nvSpPr>
+          <p:cNvPr id="36" name="Shape 34"/>
+          <p:cNvSpPr/>
+          <p:nvPr/>
+        </p:nvSpPr>
+        <p:spPr>
+          <a:xfrm>
+            <a:off x="640080" y="5010912"/>
+            <a:ext cx="7040880" cy="731520"/>
+          </a:xfrm>
+          <a:prstGeom prst="roundRect">
+            <a:avLst>
+              <a:gd name="adj" fmla="val 10000"/>
+            </a:avLst>
+          </a:prstGeom>
+          <a:solidFill>
+            <a:srgbClr val="161B22"/>
+          </a:solidFill>
+          <a:ln w="12700">
+            <a:solidFill>
+              <a:srgbClr val="30363D"/>
+            </a:solidFill>
+            <a:prstDash val="solid"/>
+          </a:ln>
+          <a:effectLst>
+            <a:outerShdw sx="100000" sy="100000" kx="0" ky="0" algn="bl" rotWithShape="0" blurRad="101600" dist="38100" dir="5400000">
+              <a:srgbClr val="000000">
+                <a:alpha val="35000"/>
+              </a:srgbClr>
+            </a:outerShdw>
+          </a:effectLst>
+        </p:spPr>
+      </p:sp>
+      <p:sp>
+        <p:nvSpPr>
+          <p:cNvPr id="37" name="Shape 35"/>
+          <p:cNvSpPr/>
+          <p:nvPr/>
+        </p:nvSpPr>
+        <p:spPr>
+          <a:xfrm>
+            <a:off x="841248" y="5157216"/>
+            <a:ext cx="438912" cy="438912"/>
+          </a:xfrm>
+          <a:prstGeom prst="ellipse">
+            <a:avLst/>
+          </a:prstGeom>
+          <a:solidFill>
+            <a:srgbClr val="58A6FF"/>
+          </a:solidFill>
+          <a:ln/>
+        </p:spPr>
+      </p:sp>
+      <p:sp>
+        <p:nvSpPr>
+          <p:cNvPr id="38" name="Text 36"/>
+          <p:cNvSpPr/>
+          <p:nvPr/>
+        </p:nvSpPr>
+        <p:spPr>
+          <a:xfrm>
+            <a:off x="841248" y="5157216"/>
+            <a:ext cx="438912" cy="438912"/>
+          </a:xfrm>
+          <a:prstGeom prst="rect">
+            <a:avLst/>
+          </a:prstGeom>
+          <a:noFill/>
+          <a:ln/>
+        </p:spPr>
+        <p:txBody>
+          <a:bodyPr wrap="square" rtlCol="0" anchor="ctr"/>
+          <a:lstStyle/>
+          <a:p>
+            <a:pPr algn="ctr" indent="0" marL="0">
               <a:buNone/>
             </a:pPr>
             <a:r>
               <a:rPr lang="en-US" sz="1500" b="1" dirty="0">
                 <a:solidFill>
+                  <a:srgbClr val="0D1117"/>
+                </a:solidFill>
+                <a:latin typeface="Calibri" pitchFamily="34" charset="0"/>
+                <a:ea typeface="Calibri" pitchFamily="34" charset="-122"/>
+                <a:cs typeface="Calibri" pitchFamily="34" charset="-120"/>
+              </a:rPr>
+              <a:t>5</a:t>
+            </a:r>
+            <a:endParaRPr lang="en-US" sz="1500" dirty="0"/>
+          </a:p>
+        </p:txBody>
+      </p:sp>
+      <p:sp>
+        <p:nvSpPr>
+          <p:cNvPr id="39" name="Text 37"/>
+          <p:cNvSpPr/>
+          <p:nvPr/>
+        </p:nvSpPr>
+        <p:spPr>
+          <a:xfrm>
+            <a:off x="1417320" y="5093208"/>
+            <a:ext cx="4297680" cy="365760"/>
+          </a:xfrm>
+          <a:prstGeom prst="rect">
+            <a:avLst/>
+          </a:prstGeom>
+          <a:noFill/>
+          <a:ln/>
+        </p:spPr>
+        <p:txBody>
+          <a:bodyPr wrap="square" lIns="0" tIns="0" rIns="0" bIns="0" rtlCol="0" anchor="ctr"/>
+          <a:lstStyle/>
+          <a:p>
+            <a:pPr indent="0" marL="0">
+              <a:buNone/>
+            </a:pPr>
+            <a:r>
+              <a:rPr lang="en-US" sz="1400" b="1" dirty="0">
+                <a:solidFill>
+                  <a:srgbClr val="E6EDF3"/>
+                </a:solidFill>
+                <a:latin typeface="Calibri" pitchFamily="34" charset="0"/>
+                <a:ea typeface="Calibri" pitchFamily="34" charset="-122"/>
+                <a:cs typeface="Calibri" pitchFamily="34" charset="-120"/>
+              </a:rPr>
+              <a:t>Self-hosted &amp; account login</a:t>
+            </a:r>
+            <a:endParaRPr lang="en-US" sz="1400" dirty="0"/>
+          </a:p>
+        </p:txBody>
+      </p:sp>
+      <p:sp>
+        <p:nvSpPr>
+          <p:cNvPr id="40" name="Text 38"/>
+          <p:cNvSpPr/>
+          <p:nvPr/>
+        </p:nvSpPr>
+        <p:spPr>
+          <a:xfrm>
+            <a:off x="1417320" y="5431536"/>
+            <a:ext cx="2926080" cy="237744"/>
+          </a:xfrm>
+          <a:prstGeom prst="rect">
+            <a:avLst/>
+          </a:prstGeom>
+          <a:noFill/>
+          <a:ln/>
+        </p:spPr>
+        <p:txBody>
+          <a:bodyPr wrap="square" lIns="0" tIns="0" rIns="0" bIns="0" rtlCol="0" anchor="ctr"/>
+          <a:lstStyle/>
+          <a:p>
+            <a:pPr indent="0" marL="0">
+              <a:buNone/>
+            </a:pPr>
+            <a:r>
+              <a:rPr lang="en-US" sz="950" b="1" dirty="0">
+                <a:solidFill>
+                  <a:srgbClr val="D29922"/>
+                </a:solidFill>
+                <a:latin typeface="Calibri" pitchFamily="34" charset="0"/>
+                <a:ea typeface="Calibri" pitchFamily="34" charset="-122"/>
+                <a:cs typeface="Calibri" pitchFamily="34" charset="-120"/>
+              </a:rPr>
+              <a:t>UNDER-PRIORITIZED</a:t>
+            </a:r>
+            <a:endParaRPr lang="en-US" sz="950" dirty="0"/>
+          </a:p>
+        </p:txBody>
+      </p:sp>
+      <p:sp>
+        <p:nvSpPr>
+          <p:cNvPr id="41" name="Text 39"/>
+          <p:cNvSpPr/>
+          <p:nvPr/>
+        </p:nvSpPr>
+        <p:spPr>
+          <a:xfrm>
+            <a:off x="5852160" y="5193792"/>
+            <a:ext cx="1005840" cy="365760"/>
+          </a:xfrm>
+          <a:prstGeom prst="rect">
+            <a:avLst/>
+          </a:prstGeom>
+          <a:noFill/>
+          <a:ln/>
+        </p:spPr>
+        <p:txBody>
+          <a:bodyPr wrap="square" lIns="0" tIns="0" rIns="0" bIns="0" rtlCol="0" anchor="ctr"/>
+          <a:lstStyle/>
+          <a:p>
+            <a:pPr indent="0" marL="0">
+              <a:buNone/>
+            </a:pPr>
+            <a:r>
+              <a:rPr lang="en-US" sz="1500" b="1" dirty="0">
+                <a:solidFill>
+                  <a:srgbClr val="58A6FF"/>
+                </a:solidFill>
+                <a:latin typeface="Calibri" pitchFamily="34" charset="0"/>
+                <a:ea typeface="Calibri" pitchFamily="34" charset="-122"/>
+                <a:cs typeface="Calibri" pitchFamily="34" charset="-120"/>
+              </a:rPr>
+              <a:t>57%</a:t>
+            </a:r>
+            <a:endParaRPr lang="en-US" sz="1500" dirty="0"/>
+          </a:p>
+        </p:txBody>
+      </p:sp>
+      <p:sp>
+        <p:nvSpPr>
+          <p:cNvPr id="42" name="Shape 40"/>
+          <p:cNvSpPr/>
+          <p:nvPr/>
+        </p:nvSpPr>
+        <p:spPr>
+          <a:xfrm>
+            <a:off x="7863840" y="5010912"/>
+            <a:ext cx="3657600" cy="731520"/>
+          </a:xfrm>
+          <a:prstGeom prst="roundRect">
+            <a:avLst>
+              <a:gd name="adj" fmla="val 10000"/>
+            </a:avLst>
+          </a:prstGeom>
+          <a:solidFill>
+            <a:srgbClr val="0F2A17"/>
+          </a:solidFill>
+          <a:ln w="12700">
+            <a:solidFill>
+              <a:srgbClr val="30363D"/>
+            </a:solidFill>
+            <a:prstDash val="solid"/>
+          </a:ln>
+          <a:effectLst>
+            <a:outerShdw sx="100000" sy="100000" kx="0" ky="0" algn="bl" rotWithShape="0" blurRad="101600" dist="38100" dir="5400000">
+              <a:srgbClr val="000000">
+                <a:alpha val="35000"/>
+              </a:srgbClr>
+            </a:outerShdw>
+          </a:effectLst>
+        </p:spPr>
+      </p:sp>
+      <p:sp>
+        <p:nvSpPr>
+          <p:cNvPr id="43" name="Text 41"/>
+          <p:cNvSpPr/>
+          <p:nvPr/>
+        </p:nvSpPr>
+        <p:spPr>
+          <a:xfrm>
+            <a:off x="8046720" y="5212080"/>
+            <a:ext cx="3383280" cy="365760"/>
+          </a:xfrm>
+          <a:prstGeom prst="rect">
+            <a:avLst/>
+          </a:prstGeom>
+          <a:noFill/>
+          <a:ln/>
+        </p:spPr>
+        <p:txBody>
+          <a:bodyPr wrap="square" lIns="0" tIns="0" rIns="0" bIns="0" rtlCol="0" anchor="ctr"/>
+          <a:lstStyle/>
+          <a:p>
+            <a:pPr indent="0" marL="0">
+              <a:buNone/>
+            </a:pPr>
+            <a:r>
+              <a:rPr lang="en-US" sz="1300" b="1" dirty="0">
+                <a:solidFill>
                   <a:srgbClr val="3FB950"/>
                 </a:solidFill>
                 <a:latin typeface="Calibri" pitchFamily="34" charset="0"/>
                 <a:ea typeface="Calibri" pitchFamily="34" charset="-122"/>
                 <a:cs typeface="Calibri" pitchFamily="34" charset="-120"/>
               </a:rPr>
-              <a:t>shipped GH-6955  </a:t>
-            </a:r>
-            <a:pPr indent="0" marL="0">
-              <a:buNone/>
-            </a:pPr>
-            <a:r>
-              <a:rPr lang="en-US" sz="1500" b="1" dirty="0">
-                <a:solidFill>
-                  <a:srgbClr val="E6EDF3"/>
-                </a:solidFill>
-                <a:latin typeface="Calibri" pitchFamily="34" charset="0"/>
-                <a:ea typeface="Calibri" pitchFamily="34" charset="-122"/>
-                <a:cs typeface="Calibri" pitchFamily="34" charset="-120"/>
-              </a:rPr>
-              <a:t>+11 mo</a:t>
-            </a:r>
-            <a:endParaRPr lang="en-US" sz="1500" dirty="0"/>
-          </a:p>
-        </p:txBody>
-      </p:sp>
-      <p:sp>
-        <p:nvSpPr>
-          <p:cNvPr id="28" name="Text 26"/>
-          <p:cNvSpPr/>
-          <p:nvPr/>
-        </p:nvSpPr>
-        <p:spPr>
-          <a:xfrm>
-            <a:off x="640080" y="5212080"/>
+              <a:t>+10 mo · GH-5843</a:t>
+            </a:r>
+            <a:endParaRPr lang="en-US" sz="1300" dirty="0"/>
+          </a:p>
+        </p:txBody>
+      </p:sp>
+      <p:sp>
+        <p:nvSpPr>
+          <p:cNvPr id="44" name="Text 42"/>
+          <p:cNvSpPr/>
+          <p:nvPr/>
+        </p:nvSpPr>
+        <p:spPr>
+          <a:xfrm>
+            <a:off x="640080" y="6035040"/>
             <a:ext cx="10881360" cy="365760"/>
           </a:xfrm>
           <a:prstGeom prst="rect">
@@ -6185,7 +6709,7 @@
               <a:buNone/>
             </a:pPr>
             <a:r>
-              <a:rPr lang="en-US" sz="1300" dirty="0">
+              <a:rPr lang="en-US" sz="1200" dirty="0">
                 <a:solidFill>
                   <a:srgbClr val="8B949E"/>
                 </a:solidFill>
@@ -6193,9 +6717,9 @@
                 <a:ea typeface="Calibri" pitchFamily="34" charset="-122"/>
                 <a:cs typeface="Calibri" pitchFamily="34" charset="-120"/>
               </a:rPr>
-              <a:t>4 116 signals  ·  1 719-item T0 roadmap  ·  every gap traces to signal IDs — no evidence, no gap.</a:t>
-            </a:r>
-            <a:endParaRPr lang="en-US" sz="1300" dirty="0"/>
+              <a:t>4 116 signals · 1 719-item T0 roadmap · confidence calibrated on 15 backtested gaps · every gap traces to IDs.</a:t>
+            </a:r>
+            <a:endParaRPr lang="en-US" sz="1200" dirty="0"/>
           </a:p>
         </p:txBody>
       </p:sp>
@@ -7171,7 +7695,7 @@
                 <a:ea typeface="Calibri" pitchFamily="34" charset="-122"/>
                 <a:cs typeface="Calibri" pitchFamily="34" charset="-120"/>
               </a:rPr>
-              <a:t>And we only say “calibrated” when the backtest gives enough labels to fit — otherwise we say so.</a:t>
+              <a:t>This run it IS calibrated — logistic fit on 15 backtested gaps (11 corroborated). No labels? We say so.</a:t>
             </a:r>
             <a:endParaRPr lang="en-US" sz="1500" dirty="0"/>
           </a:p>
@@ -7955,7 +8479,7 @@
                 <a:ea typeface="Calibri" pitchFamily="34" charset="-122"/>
                 <a:cs typeface="Calibri" pitchFamily="34" charset="-120"/>
               </a:rPr>
-              <a:t>From 2016-only data we flagged 3 under-prioritized needs. </a:t>
+              <a:t>From 2016-only data — 5 latent needs the roadmap missed. </a:t>
             </a:r>
             <a:pPr indent="0" marL="0">
               <a:lnSpc>
@@ -7972,7 +8496,7 @@
                 <a:ea typeface="Calibri" pitchFamily="34" charset="-122"/>
                 <a:cs typeface="Calibri" pitchFamily="34" charset="-120"/>
               </a:rPr>
-              <a:t>The team shipped fixes for all three within 2–11 months.</a:t>
+              <a:t>The team shipped 4 within 8–10 months; the #1 is still unfixed.</a:t>
             </a:r>
             <a:endParaRPr lang="en-US" sz="2000" dirty="0"/>
           </a:p>

</xml_diff>

<commit_message>
docs: refresh all artifacts for the corrected gpt-5.1 run
Numbers/story updated everywhere (deck HTML, .pptx, SUBMISSION, README, PITCH,
PITCH_SCRIPT) after the review fixes changed the result:
- 5 gaps: 4 UNDER-PRIORITIZED + 1 MISUNDERSTOOD (no self-contradicting IGNORED)
- the team addressed every gap, but 8–27 months late (GH-8300/6654/8460/8384/6717)
- backtest confirmed 13/15 gaps genuine; confidence 50–71% (varies), honestly
  uncalibrated (labels too skewed to fit a real curve)

Co-Authored-By: Claude Opus 4.8 <noreply@anthropic.com>
</commit_message>
<xml_diff>
--- a/docs/Silent_Stakeholder_Pitch.pptx
+++ b/docs/Silent_Stakeholder_Pitch.pptx
@@ -5263,7 +5263,7 @@
                 <a:ea typeface="Calibri" pitchFamily="34" charset="-122"/>
                 <a:cs typeface="Calibri" pitchFamily="34" charset="-120"/>
               </a:rPr>
-              <a:t>Roadmap missed 5 needs — 4 shipped 8–10 months later</a:t>
+              <a:t>Roadmap missed 5 needs — team fixed all 5, 8–27 months late</a:t>
             </a:r>
             <a:endParaRPr lang="en-US" sz="3200" dirty="0"/>
           </a:p>
@@ -5395,7 +5395,7 @@
                 <a:ea typeface="Calibri" pitchFamily="34" charset="-122"/>
                 <a:cs typeface="Calibri" pitchFamily="34" charset="-120"/>
               </a:rPr>
-              <a:t>Clear errors when creating an account</a:t>
+              <a:t>Publishing that reliably works (no 403s)</a:t>
             </a:r>
             <a:endParaRPr lang="en-US" sz="1400" dirty="0"/>
           </a:p>
@@ -5428,13 +5428,13 @@
             <a:r>
               <a:rPr lang="en-US" sz="950" b="1" dirty="0">
                 <a:solidFill>
-                  <a:srgbClr val="F85149"/>
-                </a:solidFill>
-                <a:latin typeface="Calibri" pitchFamily="34" charset="0"/>
-                <a:ea typeface="Calibri" pitchFamily="34" charset="-122"/>
-                <a:cs typeface="Calibri" pitchFamily="34" charset="-120"/>
-              </a:rPr>
-              <a:t>IGNORED</a:t>
+                  <a:srgbClr val="D29922"/>
+                </a:solidFill>
+                <a:latin typeface="Calibri" pitchFamily="34" charset="0"/>
+                <a:ea typeface="Calibri" pitchFamily="34" charset="-122"/>
+                <a:cs typeface="Calibri" pitchFamily="34" charset="-120"/>
+              </a:rPr>
+              <a:t>UNDER-PRIORITIZED</a:t>
             </a:r>
             <a:endParaRPr lang="en-US" sz="950" dirty="0"/>
           </a:p>
@@ -5473,7 +5473,7 @@
                 <a:ea typeface="Calibri" pitchFamily="34" charset="-122"/>
                 <a:cs typeface="Calibri" pitchFamily="34" charset="-120"/>
               </a:rPr>
-              <a:t>63%</a:t>
+              <a:t>71%</a:t>
             </a:r>
             <a:endParaRPr lang="en-US" sz="1500" dirty="0"/>
           </a:p>
@@ -5496,7 +5496,7 @@
             </a:avLst>
           </a:prstGeom>
           <a:solidFill>
-            <a:srgbClr val="2A0F12"/>
+            <a:srgbClr val="0F2A17"/>
           </a:solidFill>
           <a:ln w="12700">
             <a:solidFill>
@@ -5540,13 +5540,13 @@
             <a:r>
               <a:rPr lang="en-US" sz="1300" b="1" dirty="0">
                 <a:solidFill>
-                  <a:srgbClr val="F85149"/>
-                </a:solidFill>
-                <a:latin typeface="Calibri" pitchFamily="34" charset="0"/>
-                <a:ea typeface="Calibri" pitchFamily="34" charset="-122"/>
-                <a:cs typeface="Calibri" pitchFamily="34" charset="-120"/>
-              </a:rPr>
-              <a:t>still unfixed today</a:t>
+                  <a:srgbClr val="3FB950"/>
+                </a:solidFill>
+                <a:latin typeface="Calibri" pitchFamily="34" charset="0"/>
+                <a:ea typeface="Calibri" pitchFamily="34" charset="-122"/>
+                <a:cs typeface="Calibri" pitchFamily="34" charset="-120"/>
+              </a:rPr>
+              <a:t>+20 mo · GH-8300</a:t>
             </a:r>
             <a:endParaRPr lang="en-US" sz="1300" dirty="0"/>
           </a:p>
@@ -5678,7 +5678,7 @@
                 <a:ea typeface="Calibri" pitchFamily="34" charset="-122"/>
                 <a:cs typeface="Calibri" pitchFamily="34" charset="-120"/>
               </a:rPr>
-              <a:t>Reliable video attachment in posts</a:t>
+              <a:t>Video attachment in posts that sticks</a:t>
             </a:r>
             <a:endParaRPr lang="en-US" sz="1400" dirty="0"/>
           </a:p>
@@ -5711,13 +5711,13 @@
             <a:r>
               <a:rPr lang="en-US" sz="950" b="1" dirty="0">
                 <a:solidFill>
-                  <a:srgbClr val="F85149"/>
-                </a:solidFill>
-                <a:latin typeface="Calibri" pitchFamily="34" charset="0"/>
-                <a:ea typeface="Calibri" pitchFamily="34" charset="-122"/>
-                <a:cs typeface="Calibri" pitchFamily="34" charset="-120"/>
-              </a:rPr>
-              <a:t>IGNORED</a:t>
+                  <a:srgbClr val="D29922"/>
+                </a:solidFill>
+                <a:latin typeface="Calibri" pitchFamily="34" charset="0"/>
+                <a:ea typeface="Calibri" pitchFamily="34" charset="-122"/>
+                <a:cs typeface="Calibri" pitchFamily="34" charset="-120"/>
+              </a:rPr>
+              <a:t>UNDER-PRIORITIZED</a:t>
             </a:r>
             <a:endParaRPr lang="en-US" sz="950" dirty="0"/>
           </a:p>
@@ -5756,7 +5756,7 @@
                 <a:ea typeface="Calibri" pitchFamily="34" charset="-122"/>
                 <a:cs typeface="Calibri" pitchFamily="34" charset="-120"/>
               </a:rPr>
-              <a:t>63%</a:t>
+              <a:t>67%</a:t>
             </a:r>
             <a:endParaRPr lang="en-US" sz="1500" dirty="0"/>
           </a:p>
@@ -5961,7 +5961,7 @@
                 <a:ea typeface="Calibri" pitchFamily="34" charset="-122"/>
                 <a:cs typeface="Calibri" pitchFamily="34" charset="-120"/>
               </a:rPr>
-              <a:t>Posts load &amp; refresh after login</a:t>
+              <a:t>Account creation without mysterious errors</a:t>
             </a:r>
             <a:endParaRPr lang="en-US" sz="1400" dirty="0"/>
           </a:p>
@@ -5994,13 +5994,13 @@
             <a:r>
               <a:rPr lang="en-US" sz="950" b="1" dirty="0">
                 <a:solidFill>
-                  <a:srgbClr val="F85149"/>
-                </a:solidFill>
-                <a:latin typeface="Calibri" pitchFamily="34" charset="0"/>
-                <a:ea typeface="Calibri" pitchFamily="34" charset="-122"/>
-                <a:cs typeface="Calibri" pitchFamily="34" charset="-120"/>
-              </a:rPr>
-              <a:t>IGNORED</a:t>
+                  <a:srgbClr val="D29922"/>
+                </a:solidFill>
+                <a:latin typeface="Calibri" pitchFamily="34" charset="0"/>
+                <a:ea typeface="Calibri" pitchFamily="34" charset="-122"/>
+                <a:cs typeface="Calibri" pitchFamily="34" charset="-120"/>
+              </a:rPr>
+              <a:t>UNDER-PRIORITIZED</a:t>
             </a:r>
             <a:endParaRPr lang="en-US" sz="950" dirty="0"/>
           </a:p>
@@ -6039,7 +6039,7 @@
                 <a:ea typeface="Calibri" pitchFamily="34" charset="-122"/>
                 <a:cs typeface="Calibri" pitchFamily="34" charset="-120"/>
               </a:rPr>
-              <a:t>62%</a:t>
+              <a:t>65%</a:t>
             </a:r>
             <a:endParaRPr lang="en-US" sz="1500" dirty="0"/>
           </a:p>
@@ -6112,7 +6112,7 @@
                 <a:ea typeface="Calibri" pitchFamily="34" charset="-122"/>
                 <a:cs typeface="Calibri" pitchFamily="34" charset="-120"/>
               </a:rPr>
-              <a:t>+10 mo · GH-5874</a:t>
+              <a:t>+27 mo · GH-8460</a:t>
             </a:r>
             <a:endParaRPr lang="en-US" sz="1300" dirty="0"/>
           </a:p>
@@ -6244,7 +6244,7 @@
                 <a:ea typeface="Calibri" pitchFamily="34" charset="-122"/>
                 <a:cs typeface="Calibri" pitchFamily="34" charset="-120"/>
               </a:rPr>
-              <a:t>Reply / comment on comments in-app</a:t>
+              <a:t>Posts reliably load &amp; refresh over time</a:t>
             </a:r>
             <a:endParaRPr lang="en-US" sz="1400" dirty="0"/>
           </a:p>
@@ -6322,7 +6322,7 @@
                 <a:ea typeface="Calibri" pitchFamily="34" charset="-122"/>
                 <a:cs typeface="Calibri" pitchFamily="34" charset="-120"/>
               </a:rPr>
-              <a:t>57%</a:t>
+              <a:t>64%</a:t>
             </a:r>
             <a:endParaRPr lang="en-US" sz="1500" dirty="0"/>
           </a:p>
@@ -6395,7 +6395,7 @@
                 <a:ea typeface="Calibri" pitchFamily="34" charset="-122"/>
                 <a:cs typeface="Calibri" pitchFamily="34" charset="-120"/>
               </a:rPr>
-              <a:t>+9 mo · GH-6769</a:t>
+              <a:t>+21 mo · GH-8384</a:t>
             </a:r>
             <a:endParaRPr lang="en-US" sz="1300" dirty="0"/>
           </a:p>
@@ -6527,7 +6527,7 @@
                 <a:ea typeface="Calibri" pitchFamily="34" charset="-122"/>
                 <a:cs typeface="Calibri" pitchFamily="34" charset="-120"/>
               </a:rPr>
-              <a:t>Self-hosted &amp; account login</a:t>
+              <a:t>A comments experience you can navigate</a:t>
             </a:r>
             <a:endParaRPr lang="en-US" sz="1400" dirty="0"/>
           </a:p>
@@ -6560,13 +6560,13 @@
             <a:r>
               <a:rPr lang="en-US" sz="950" b="1" dirty="0">
                 <a:solidFill>
-                  <a:srgbClr val="D29922"/>
-                </a:solidFill>
-                <a:latin typeface="Calibri" pitchFamily="34" charset="0"/>
-                <a:ea typeface="Calibri" pitchFamily="34" charset="-122"/>
-                <a:cs typeface="Calibri" pitchFamily="34" charset="-120"/>
-              </a:rPr>
-              <a:t>UNDER-PRIORITIZED</a:t>
+                  <a:srgbClr val="A371F7"/>
+                </a:solidFill>
+                <a:latin typeface="Calibri" pitchFamily="34" charset="0"/>
+                <a:ea typeface="Calibri" pitchFamily="34" charset="-122"/>
+                <a:cs typeface="Calibri" pitchFamily="34" charset="-120"/>
+              </a:rPr>
+              <a:t>MISUNDERSTOOD</a:t>
             </a:r>
             <a:endParaRPr lang="en-US" sz="950" dirty="0"/>
           </a:p>
@@ -6605,7 +6605,7 @@
                 <a:ea typeface="Calibri" pitchFamily="34" charset="-122"/>
                 <a:cs typeface="Calibri" pitchFamily="34" charset="-120"/>
               </a:rPr>
-              <a:t>57%</a:t>
+              <a:t>50%</a:t>
             </a:r>
             <a:endParaRPr lang="en-US" sz="1500" dirty="0"/>
           </a:p>
@@ -6678,7 +6678,7 @@
                 <a:ea typeface="Calibri" pitchFamily="34" charset="-122"/>
                 <a:cs typeface="Calibri" pitchFamily="34" charset="-120"/>
               </a:rPr>
-              <a:t>+10 mo · GH-5843</a:t>
+              <a:t>+9 mo · GH-6717</a:t>
             </a:r>
             <a:endParaRPr lang="en-US" sz="1300" dirty="0"/>
           </a:p>
@@ -6717,7 +6717,7 @@
                 <a:ea typeface="Calibri" pitchFamily="34" charset="-122"/>
                 <a:cs typeface="Calibri" pitchFamily="34" charset="-120"/>
               </a:rPr>
-              <a:t>4 116 signals · 1 719-item T0 roadmap · confidence calibrated on 15 backtested gaps · every gap traces to IDs.</a:t>
+              <a:t>4 116 signals · 1 719-item T0 roadmap · backtest confirmed 13/15 gaps genuine · every gap traces to IDs.</a:t>
             </a:r>
             <a:endParaRPr lang="en-US" sz="1200" dirty="0"/>
           </a:p>
@@ -7695,7 +7695,7 @@
                 <a:ea typeface="Calibri" pitchFamily="34" charset="-122"/>
                 <a:cs typeface="Calibri" pitchFamily="34" charset="-120"/>
               </a:rPr>
-              <a:t>This run it IS calibrated — logistic fit on 15 backtested gaps (11 corroborated). No labels? We say so.</a:t>
+              <a:t>Scores vary (50–71%). Backtest confirmed 13/15 genuine — too skewed to fake a calibration curve, so we keep the transparent score and say so.</a:t>
             </a:r>
             <a:endParaRPr lang="en-US" sz="1500" dirty="0"/>
           </a:p>
@@ -8496,7 +8496,7 @@
                 <a:ea typeface="Calibri" pitchFamily="34" charset="-122"/>
                 <a:cs typeface="Calibri" pitchFamily="34" charset="-120"/>
               </a:rPr>
-              <a:t>The team shipped 4 within 8–10 months; the #1 is still unfixed.</a:t>
+              <a:t>The team fixed all five, 8–27 months late; backtest confirmed 13/15 genuine.</a:t>
             </a:r>
             <a:endParaRPr lang="en-US" sz="2000" dirty="0"/>
           </a:p>

</xml_diff>